<commit_message>
working on solving DHARMa residuals (underdispersion issue)
</commit_message>
<xml_diff>
--- a/Figure Curation PVR VRG.pptx
+++ b/Figure Curation PVR VRG.pptx
@@ -105,6 +105,11 @@
       </a:defRPr>
     </a:lvl9pPr>
   </p:defaultTextStyle>
+  <p:extLst>
+    <p:ext uri="{EFAFB233-063F-42B5-8137-9DF3F51BA10A}">
+      <p15:sldGuideLst xmlns:p15="http://schemas.microsoft.com/office/powerpoint/2012/main"/>
+    </p:ext>
+  </p:extLst>
 </p:presentation>
 </file>
 
@@ -3637,7 +3642,7 @@
         <p:spPr>
           <a:xfrm>
             <a:off x="10557587" y="3613666"/>
-            <a:ext cx="1377349" cy="1200329"/>
+            <a:ext cx="1377349" cy="1046440"/>
           </a:xfrm>
           <a:prstGeom prst="rect">
             <a:avLst/>
@@ -3661,7 +3666,7 @@
           <a:p>
             <a:r>
               <a:rPr lang="en-US" sz="1000" dirty="0"/>
-              <a:t>-Relief index is the dominant driver (except for at non-MPA sites) </a:t>
+              <a:t>-Relief index is the dominant driver (only at MPA sites) </a:t>
             </a:r>
           </a:p>
           <a:p>
@@ -3944,7 +3949,7 @@
             </a:pPr>
             <a:r>
               <a:rPr lang="en-US" sz="1000" dirty="0"/>
-              <a:t>Relief index positively predicts density -&gt; sign</a:t>
+              <a:t>Relief index positively predicts density </a:t>
             </a:r>
           </a:p>
           <a:p>
@@ -4073,13 +4078,8 @@
             <a:pPr fontAlgn="base"/>
             <a:r>
               <a:rPr lang="en-US" sz="1000" dirty="0"/>
-              <a:t>- There is a dip during wasting following by </a:t>
-            </a:r>
-            <a:r>
-              <a:rPr lang="en-US" sz="1000"/>
-              <a:t>partial recovery </a:t>
-            </a:r>
-            <a:endParaRPr lang="en-US" sz="1000" dirty="0"/>
+              <a:t>- There is a dip during wasting following by partial recovery </a:t>
+            </a:r>
           </a:p>
           <a:p>
             <a:pPr fontAlgn="base"/>

</xml_diff>